<commit_message>
feat(02-example): unify export asset resolution into single prepareExport phase
Preflight, fidelity accounting, and the PPTX exporter now consume one frozen
PreparedExport (canonical asset registry + snapshots). An unresolved required
visible image blocks a Fidelity First export before READY, named by block id
and source URL instead of a synthetic inline-image id. Adds updateImageSource
command, atomic editor image-source wiring, and e2e coverage for the blocked
and recovered export flows.
</commit_message>
<xml_diff>
--- a/examples/02-example/evidence/weight-of-the-web.pptx
+++ b/examples/02-example/evidence/weight-of-the-web.pptx
@@ -170,7 +170,7 @@
           </c:tx>
           <c:spPr>
             <a:solidFill>
-              <a:srgbClr val="C0504D"/>
+              <a:srgbClr val="2B2118"/>
             </a:solidFill>
             <a:effectLst/>
           </c:spPr>
@@ -184,7 +184,7 @@
                 <a:pPr>
                   <a:defRPr b="1" i="0" strike="noStrike" sz="1000" u="none">
                     <a:solidFill>
-                      <a:srgbClr val="555555"/>
+                      <a:srgbClr val="0F172A"/>
                     </a:solidFill>
                     <a:latin typeface="Arial"/>
                   </a:defRPr>
@@ -199,6 +199,61 @@
             <c:showBubbleSize val="0"/>
             <c:showLeaderLines val="0"/>
           </c:dLbls>
+          <c:dPt>
+            <c:idx val="0"/>
+            <c:invertIfNegative val="0"/>
+            <c:bubble3D val="0"/>
+            <c:spPr>
+              <a:solidFill>
+                <a:srgbClr val="2B2118"/>
+              </a:solidFill>
+              <a:effectLst/>
+            </c:spPr>
+          </c:dPt>
+          <c:dPt>
+            <c:idx val="1"/>
+            <c:invertIfNegative val="0"/>
+            <c:bubble3D val="0"/>
+            <c:spPr>
+              <a:solidFill>
+                <a:srgbClr val="2B2118"/>
+              </a:solidFill>
+              <a:effectLst/>
+            </c:spPr>
+          </c:dPt>
+          <c:dPt>
+            <c:idx val="2"/>
+            <c:invertIfNegative val="0"/>
+            <c:bubble3D val="0"/>
+            <c:spPr>
+              <a:solidFill>
+                <a:srgbClr val="2B2118"/>
+              </a:solidFill>
+              <a:effectLst/>
+            </c:spPr>
+          </c:dPt>
+          <c:dPt>
+            <c:idx val="3"/>
+            <c:invertIfNegative val="0"/>
+            <c:bubble3D val="0"/>
+            <c:spPr>
+              <a:solidFill>
+                <a:srgbClr val="2B2118"/>
+              </a:solidFill>
+              <a:effectLst/>
+            </c:spPr>
+          </c:dPt>
+          <c:dPt>
+            <c:idx val="4"/>
+            <c:invertIfNegative val="0"/>
+            <c:bubble3D val="0"/>
+            <c:spPr>
+              <a:solidFill>
+                <a:srgbClr val="B45309"/>
+              </a:solidFill>
+              <a:effectLst/>
+            </c:spPr>
+          </c:dPt>
           <c:cat>
             <c:multiLvlStrRef>
               <c:f>Sheet1!$A$2:$A$6</c:f>
@@ -258,7 +313,7 @@
               <a:pPr>
                 <a:defRPr b="1" i="0" strike="noStrike" sz="1000" u="none">
                   <a:solidFill>
-                    <a:srgbClr val="555555"/>
+                    <a:srgbClr val="0F172A"/>
                   </a:solidFill>
                   <a:latin typeface="Arial"/>
                 </a:defRPr>
@@ -304,7 +359,7 @@
           <a:lstStyle/>
           <a:p>
             <a:pPr>
-              <a:defRPr sz="900" b="0" i="0" u="none" strike="noStrike">
+              <a:defRPr sz="1000" b="0" i="0" u="none" strike="noStrike">
                 <a:solidFill>
                   <a:srgbClr val="000000"/>
                 </a:solidFill>
@@ -451,7 +506,7 @@
           </c:tx>
           <c:spPr>
             <a:solidFill>
-              <a:srgbClr val="C0504D"/>
+              <a:srgbClr val="2B2118"/>
             </a:solidFill>
             <a:effectLst/>
           </c:spPr>
@@ -465,7 +520,7 @@
                 <a:pPr>
                   <a:defRPr b="1" i="0" strike="noStrike" sz="1000" u="none">
                     <a:solidFill>
-                      <a:srgbClr val="555555"/>
+                      <a:srgbClr val="0F172A"/>
                     </a:solidFill>
                     <a:latin typeface="Arial"/>
                   </a:defRPr>
@@ -480,6 +535,105 @@
             <c:showBubbleSize val="0"/>
             <c:showLeaderLines val="0"/>
           </c:dLbls>
+          <c:dPt>
+            <c:idx val="0"/>
+            <c:invertIfNegative val="0"/>
+            <c:bubble3D val="0"/>
+            <c:spPr>
+              <a:solidFill>
+                <a:srgbClr val="2B2118"/>
+              </a:solidFill>
+              <a:effectLst/>
+            </c:spPr>
+          </c:dPt>
+          <c:dPt>
+            <c:idx val="1"/>
+            <c:invertIfNegative val="0"/>
+            <c:bubble3D val="0"/>
+            <c:spPr>
+              <a:solidFill>
+                <a:srgbClr val="2B2118"/>
+              </a:solidFill>
+              <a:effectLst/>
+            </c:spPr>
+          </c:dPt>
+          <c:dPt>
+            <c:idx val="2"/>
+            <c:invertIfNegative val="0"/>
+            <c:bubble3D val="0"/>
+            <c:spPr>
+              <a:solidFill>
+                <a:srgbClr val="2B2118"/>
+              </a:solidFill>
+              <a:effectLst/>
+            </c:spPr>
+          </c:dPt>
+          <c:dPt>
+            <c:idx val="3"/>
+            <c:invertIfNegative val="0"/>
+            <c:bubble3D val="0"/>
+            <c:spPr>
+              <a:solidFill>
+                <a:srgbClr val="2B2118"/>
+              </a:solidFill>
+              <a:effectLst/>
+            </c:spPr>
+          </c:dPt>
+          <c:dPt>
+            <c:idx val="4"/>
+            <c:invertIfNegative val="0"/>
+            <c:bubble3D val="0"/>
+            <c:spPr>
+              <a:solidFill>
+                <a:srgbClr val="2B2118"/>
+              </a:solidFill>
+              <a:effectLst/>
+            </c:spPr>
+          </c:dPt>
+          <c:dPt>
+            <c:idx val="5"/>
+            <c:invertIfNegative val="0"/>
+            <c:bubble3D val="0"/>
+            <c:spPr>
+              <a:solidFill>
+                <a:srgbClr val="2B2118"/>
+              </a:solidFill>
+              <a:effectLst/>
+            </c:spPr>
+          </c:dPt>
+          <c:dPt>
+            <c:idx val="6"/>
+            <c:invertIfNegative val="0"/>
+            <c:bubble3D val="0"/>
+            <c:spPr>
+              <a:solidFill>
+                <a:srgbClr val="2B2118"/>
+              </a:solidFill>
+              <a:effectLst/>
+            </c:spPr>
+          </c:dPt>
+          <c:dPt>
+            <c:idx val="7"/>
+            <c:invertIfNegative val="0"/>
+            <c:bubble3D val="0"/>
+            <c:spPr>
+              <a:solidFill>
+                <a:srgbClr val="2B2118"/>
+              </a:solidFill>
+              <a:effectLst/>
+            </c:spPr>
+          </c:dPt>
+          <c:dPt>
+            <c:idx val="8"/>
+            <c:invertIfNegative val="0"/>
+            <c:bubble3D val="0"/>
+            <c:spPr>
+              <a:solidFill>
+                <a:srgbClr val="B45309"/>
+              </a:solidFill>
+              <a:effectLst/>
+            </c:spPr>
+          </c:dPt>
           <c:cat>
             <c:multiLvlStrRef>
               <c:f>Sheet1!$A$2:$A$10</c:f>
@@ -563,7 +717,7 @@
               <a:pPr>
                 <a:defRPr b="1" i="0" strike="noStrike" sz="1000" u="none">
                   <a:solidFill>
-                    <a:srgbClr val="555555"/>
+                    <a:srgbClr val="0F172A"/>
                   </a:solidFill>
                   <a:latin typeface="Arial"/>
                 </a:defRPr>
@@ -609,7 +763,7 @@
           <a:lstStyle/>
           <a:p>
             <a:pPr>
-              <a:defRPr sz="900" b="0" i="0" u="none" strike="noStrike">
+              <a:defRPr sz="1000" b="0" i="0" u="none" strike="noStrike">
                 <a:solidFill>
                   <a:srgbClr val="000000"/>
                 </a:solidFill>
@@ -737,7 +891,7 @@
     <c:plotArea>
       <c:layout/>
       <c:barChart>
-        <c:barDir val="col"/>
+        <c:barDir val="bar"/>
         <c:grouping val="clustered"/>
         <c:varyColors val="0"/>
         <c:ser>
@@ -756,7 +910,7 @@
           </c:tx>
           <c:spPr>
             <a:solidFill>
-              <a:srgbClr val="C0504D"/>
+              <a:srgbClr val="B45309"/>
             </a:solidFill>
             <a:effectLst/>
           </c:spPr>
@@ -770,7 +924,7 @@
                 <a:pPr>
                   <a:defRPr b="1" i="0" strike="noStrike" sz="1000" u="none">
                     <a:solidFill>
-                      <a:srgbClr val="555555"/>
+                      <a:srgbClr val="0F172A"/>
                     </a:solidFill>
                     <a:latin typeface="Arial"/>
                   </a:defRPr>
@@ -785,6 +939,61 @@
             <c:showBubbleSize val="0"/>
             <c:showLeaderLines val="0"/>
           </c:dLbls>
+          <c:dPt>
+            <c:idx val="0"/>
+            <c:invertIfNegative val="0"/>
+            <c:bubble3D val="0"/>
+            <c:spPr>
+              <a:solidFill>
+                <a:srgbClr val="B45309"/>
+              </a:solidFill>
+              <a:effectLst/>
+            </c:spPr>
+          </c:dPt>
+          <c:dPt>
+            <c:idx val="1"/>
+            <c:invertIfNegative val="0"/>
+            <c:bubble3D val="0"/>
+            <c:spPr>
+              <a:solidFill>
+                <a:srgbClr val="2B2118"/>
+              </a:solidFill>
+              <a:effectLst/>
+            </c:spPr>
+          </c:dPt>
+          <c:dPt>
+            <c:idx val="2"/>
+            <c:invertIfNegative val="0"/>
+            <c:bubble3D val="0"/>
+            <c:spPr>
+              <a:solidFill>
+                <a:srgbClr val="2B2118"/>
+              </a:solidFill>
+              <a:effectLst/>
+            </c:spPr>
+          </c:dPt>
+          <c:dPt>
+            <c:idx val="3"/>
+            <c:invertIfNegative val="0"/>
+            <c:bubble3D val="0"/>
+            <c:spPr>
+              <a:solidFill>
+                <a:srgbClr val="2B2118"/>
+              </a:solidFill>
+              <a:effectLst/>
+            </c:spPr>
+          </c:dPt>
+          <c:dPt>
+            <c:idx val="4"/>
+            <c:invertIfNegative val="0"/>
+            <c:bubble3D val="0"/>
+            <c:spPr>
+              <a:solidFill>
+                <a:srgbClr val="2B2118"/>
+              </a:solidFill>
+              <a:effectLst/>
+            </c:spPr>
+          </c:dPt>
           <c:cat>
             <c:multiLvlStrRef>
               <c:f>Sheet1!$A$2:$A$6</c:f>
@@ -844,7 +1053,7 @@
               <a:pPr>
                 <a:defRPr b="1" i="0" strike="noStrike" sz="1000" u="none">
                   <a:solidFill>
-                    <a:srgbClr val="555555"/>
+                    <a:srgbClr val="0F172A"/>
                   </a:solidFill>
                   <a:latin typeface="Arial"/>
                 </a:defRPr>
@@ -871,11 +1080,11 @@
           <c:orientation val="minMax"/>
         </c:scaling>
         <c:delete val="0"/>
-        <c:axPos val="b"/>
+        <c:axPos val="l"/>
         <c:numFmt formatCode="General" sourceLinked="1"/>
         <c:majorTickMark val="out"/>
         <c:minorTickMark val="none"/>
-        <c:tickLblPos val="low"/>
+        <c:tickLblPos val="nextTo"/>
         <c:spPr>
           <a:ln w="12700" cap="flat">
             <a:solidFill>
@@ -890,7 +1099,7 @@
           <a:lstStyle/>
           <a:p>
             <a:pPr>
-              <a:defRPr sz="900" b="0" i="0" u="none" strike="noStrike">
+              <a:defRPr sz="1000" b="0" i="0" u="none" strike="noStrike">
                 <a:solidFill>
                   <a:srgbClr val="000000"/>
                 </a:solidFill>
@@ -912,7 +1121,7 @@
           <c:orientation val="minMax"/>
         </c:scaling>
         <c:delete val="0"/>
-        <c:axPos val="l"/>
+        <c:axPos val="b"/>
         <c:majorGridlines>
           <c:spPr>
             <a:ln w="12700" cap="flat">
@@ -927,7 +1136,7 @@
         <c:numFmt formatCode="General" sourceLinked="0"/>
         <c:majorTickMark val="out"/>
         <c:minorTickMark val="none"/>
-        <c:tickLblPos val="nextTo"/>
+        <c:tickLblPos val="low"/>
         <c:spPr>
           <a:ln w="12700" cap="flat">
             <a:solidFill>
@@ -2299,7 +2508,7 @@
             <a:r>
               <a:rPr lang="en-US" sz="720" b="1" dirty="0">
                 <a:solidFill>
-                  <a:srgbClr val="0F172A"/>
+                  <a:srgbClr val="B45309"/>
                 </a:solidFill>
                 <a:latin typeface="Arial" pitchFamily="34" charset="0"/>
                 <a:ea typeface="Arial" pitchFamily="34" charset="-122"/>
@@ -2425,7 +2634,7 @@
             <a:r>
               <a:rPr lang="en-US" sz="780" dirty="0">
                 <a:solidFill>
-                  <a:srgbClr val="0F172A"/>
+                  <a:srgbClr val="64748B"/>
                 </a:solidFill>
                 <a:latin typeface="Arial" pitchFamily="34" charset="0"/>
                 <a:ea typeface="Arial" pitchFamily="34" charset="-122"/>
@@ -2508,7 +2717,7 @@
             <a:r>
               <a:rPr lang="en-US" sz="720" b="1" dirty="0">
                 <a:solidFill>
-                  <a:srgbClr val="0F172A"/>
+                  <a:srgbClr val="B45309"/>
                 </a:solidFill>
                 <a:latin typeface="Arial" pitchFamily="34" charset="0"/>
                 <a:ea typeface="Arial" pitchFamily="34" charset="-122"/>
@@ -2716,7 +2925,7 @@
             <a:r>
               <a:rPr lang="en-US" sz="780" i="1" dirty="0">
                 <a:solidFill>
-                  <a:srgbClr val="0F172A"/>
+                  <a:srgbClr val="64748B"/>
                 </a:solidFill>
                 <a:latin typeface="Arial" pitchFamily="34" charset="0"/>
                 <a:ea typeface="Arial" pitchFamily="34" charset="-122"/>
@@ -2783,7 +2992,7 @@
             <a:r>
               <a:rPr lang="en-US" sz="720" b="1" dirty="0">
                 <a:solidFill>
-                  <a:srgbClr val="0F172A"/>
+                  <a:srgbClr val="B45309"/>
                 </a:solidFill>
                 <a:latin typeface="Arial" pitchFamily="34" charset="0"/>
                 <a:ea typeface="Arial" pitchFamily="34" charset="-122"/>
@@ -2925,7 +3134,7 @@
             <a:r>
               <a:rPr lang="en-US" sz="600" i="1" dirty="0">
                 <a:solidFill>
-                  <a:srgbClr val="0F172A"/>
+                  <a:srgbClr val="64748B"/>
                 </a:solidFill>
                 <a:latin typeface="Arial" pitchFamily="34" charset="0"/>
                 <a:ea typeface="Arial" pitchFamily="34" charset="-122"/>
@@ -2992,7 +3201,7 @@
             <a:r>
               <a:rPr lang="en-US" sz="720" b="1" dirty="0">
                 <a:solidFill>
-                  <a:srgbClr val="0F172A"/>
+                  <a:srgbClr val="B45309"/>
                 </a:solidFill>
                 <a:latin typeface="Arial" pitchFamily="34" charset="0"/>
                 <a:ea typeface="Arial" pitchFamily="34" charset="-122"/>
@@ -3199,7 +3408,7 @@
             <a:r>
               <a:rPr lang="en-US" sz="720" b="1" dirty="0">
                 <a:solidFill>
-                  <a:srgbClr val="0F172A"/>
+                  <a:srgbClr val="B45309"/>
                 </a:solidFill>
                 <a:latin typeface="Arial" pitchFamily="34" charset="0"/>
                 <a:ea typeface="Arial" pitchFamily="34" charset="-122"/>
@@ -3268,11 +3477,11 @@
             <a:avLst/>
           </a:prstGeom>
           <a:solidFill>
-            <a:srgbClr val="1A73E8"/>
+            <a:srgbClr val="2B2118"/>
           </a:solidFill>
           <a:ln w="12700">
             <a:solidFill>
-              <a:srgbClr val="1F1F1F"/>
+              <a:srgbClr val="2B2118"/>
             </a:solidFill>
           </a:ln>
         </p:spPr>
@@ -3286,7 +3495,7 @@
             <a:r>
               <a:rPr lang="en-US" sz="900" b="1" dirty="0">
                 <a:solidFill>
-                  <a:srgbClr val="F8F9FA"/>
+                  <a:srgbClr val="FAF3E7"/>
                 </a:solidFill>
                 <a:latin typeface="Arial" pitchFamily="34" charset="0"/>
                 <a:ea typeface="Arial" pitchFamily="34" charset="-122"/>
@@ -3303,7 +3512,7 @@
             <a:r>
               <a:rPr lang="en-US" sz="900" b="1" dirty="0">
                 <a:solidFill>
-                  <a:srgbClr val="F8F9FA"/>
+                  <a:srgbClr val="FAF3E7"/>
                 </a:solidFill>
                 <a:latin typeface="Arial" pitchFamily="34" charset="0"/>
                 <a:ea typeface="Arial" pitchFamily="34" charset="-122"/>
@@ -3330,11 +3539,11 @@
             <a:avLst/>
           </a:prstGeom>
           <a:solidFill>
-            <a:srgbClr val="3C4043"/>
+            <a:srgbClr val="64748B"/>
           </a:solidFill>
           <a:ln w="12700">
             <a:solidFill>
-              <a:srgbClr val="3C4043"/>
+              <a:srgbClr val="64748B"/>
             </a:solidFill>
             <a:prstDash val="solid"/>
           </a:ln>
@@ -3355,11 +3564,11 @@
             <a:avLst/>
           </a:prstGeom>
           <a:solidFill>
-            <a:srgbClr val="1A73E8"/>
+            <a:srgbClr val="2B2118"/>
           </a:solidFill>
           <a:ln w="12700">
             <a:solidFill>
-              <a:srgbClr val="1F1F1F"/>
+              <a:srgbClr val="2B2118"/>
             </a:solidFill>
           </a:ln>
         </p:spPr>
@@ -3373,7 +3582,7 @@
             <a:r>
               <a:rPr lang="en-US" sz="900" b="1" dirty="0">
                 <a:solidFill>
-                  <a:srgbClr val="F8F9FA"/>
+                  <a:srgbClr val="FAF3E7"/>
                 </a:solidFill>
                 <a:latin typeface="Arial" pitchFamily="34" charset="0"/>
                 <a:ea typeface="Arial" pitchFamily="34" charset="-122"/>
@@ -3390,7 +3599,7 @@
             <a:r>
               <a:rPr lang="en-US" sz="900" b="1" dirty="0">
                 <a:solidFill>
-                  <a:srgbClr val="F8F9FA"/>
+                  <a:srgbClr val="FAF3E7"/>
                 </a:solidFill>
                 <a:latin typeface="Arial" pitchFamily="34" charset="0"/>
                 <a:ea typeface="Arial" pitchFamily="34" charset="-122"/>
@@ -3417,11 +3626,11 @@
             <a:avLst/>
           </a:prstGeom>
           <a:solidFill>
-            <a:srgbClr val="3C4043"/>
+            <a:srgbClr val="64748B"/>
           </a:solidFill>
           <a:ln w="12700">
             <a:solidFill>
-              <a:srgbClr val="3C4043"/>
+              <a:srgbClr val="64748B"/>
             </a:solidFill>
             <a:prstDash val="solid"/>
           </a:ln>
@@ -3442,11 +3651,11 @@
             <a:avLst/>
           </a:prstGeom>
           <a:solidFill>
-            <a:srgbClr val="1A73E8"/>
+            <a:srgbClr val="2B2118"/>
           </a:solidFill>
           <a:ln w="12700">
             <a:solidFill>
-              <a:srgbClr val="1F1F1F"/>
+              <a:srgbClr val="2B2118"/>
             </a:solidFill>
           </a:ln>
         </p:spPr>
@@ -3460,7 +3669,7 @@
             <a:r>
               <a:rPr lang="en-US" sz="900" b="1" dirty="0">
                 <a:solidFill>
-                  <a:srgbClr val="F8F9FA"/>
+                  <a:srgbClr val="FAF3E7"/>
                 </a:solidFill>
                 <a:latin typeface="Arial" pitchFamily="34" charset="0"/>
                 <a:ea typeface="Arial" pitchFamily="34" charset="-122"/>
@@ -3477,7 +3686,7 @@
             <a:r>
               <a:rPr lang="en-US" sz="900" b="1" dirty="0">
                 <a:solidFill>
-                  <a:srgbClr val="F8F9FA"/>
+                  <a:srgbClr val="FAF3E7"/>
                 </a:solidFill>
                 <a:latin typeface="Arial" pitchFamily="34" charset="0"/>
                 <a:ea typeface="Arial" pitchFamily="34" charset="-122"/>
@@ -3504,11 +3713,11 @@
             <a:avLst/>
           </a:prstGeom>
           <a:solidFill>
-            <a:srgbClr val="3C4043"/>
+            <a:srgbClr val="64748B"/>
           </a:solidFill>
           <a:ln w="12700">
             <a:solidFill>
-              <a:srgbClr val="3C4043"/>
+              <a:srgbClr val="64748B"/>
             </a:solidFill>
             <a:prstDash val="solid"/>
           </a:ln>
@@ -3529,11 +3738,11 @@
             <a:avLst/>
           </a:prstGeom>
           <a:solidFill>
-            <a:srgbClr val="1A73E8"/>
+            <a:srgbClr val="2B2118"/>
           </a:solidFill>
           <a:ln w="12700">
             <a:solidFill>
-              <a:srgbClr val="1F1F1F"/>
+              <a:srgbClr val="2B2118"/>
             </a:solidFill>
           </a:ln>
         </p:spPr>
@@ -3547,7 +3756,7 @@
             <a:r>
               <a:rPr lang="en-US" sz="900" b="1" dirty="0">
                 <a:solidFill>
-                  <a:srgbClr val="F8F9FA"/>
+                  <a:srgbClr val="FAF3E7"/>
                 </a:solidFill>
                 <a:latin typeface="Arial" pitchFamily="34" charset="0"/>
                 <a:ea typeface="Arial" pitchFamily="34" charset="-122"/>
@@ -3564,7 +3773,7 @@
             <a:r>
               <a:rPr lang="en-US" sz="900" b="1" dirty="0">
                 <a:solidFill>
-                  <a:srgbClr val="F8F9FA"/>
+                  <a:srgbClr val="FAF3E7"/>
                 </a:solidFill>
                 <a:latin typeface="Arial" pitchFamily="34" charset="0"/>
                 <a:ea typeface="Arial" pitchFamily="34" charset="-122"/>
@@ -3591,11 +3800,11 @@
             <a:avLst/>
           </a:prstGeom>
           <a:solidFill>
-            <a:srgbClr val="3C4043"/>
+            <a:srgbClr val="64748B"/>
           </a:solidFill>
           <a:ln w="12700">
             <a:solidFill>
-              <a:srgbClr val="3C4043"/>
+              <a:srgbClr val="64748B"/>
             </a:solidFill>
             <a:prstDash val="solid"/>
           </a:ln>
@@ -3616,11 +3825,11 @@
             <a:avLst/>
           </a:prstGeom>
           <a:solidFill>
-            <a:srgbClr val="1A73E8"/>
+            <a:srgbClr val="2B2118"/>
           </a:solidFill>
           <a:ln w="12700">
             <a:solidFill>
-              <a:srgbClr val="1F1F1F"/>
+              <a:srgbClr val="2B2118"/>
             </a:solidFill>
           </a:ln>
         </p:spPr>
@@ -3634,7 +3843,7 @@
             <a:r>
               <a:rPr lang="en-US" sz="900" b="1" dirty="0">
                 <a:solidFill>
-                  <a:srgbClr val="F8F9FA"/>
+                  <a:srgbClr val="FAF3E7"/>
                 </a:solidFill>
                 <a:latin typeface="Arial" pitchFamily="34" charset="0"/>
                 <a:ea typeface="Arial" pitchFamily="34" charset="-122"/>
@@ -3651,7 +3860,7 @@
             <a:r>
               <a:rPr lang="en-US" sz="900" b="1" dirty="0">
                 <a:solidFill>
-                  <a:srgbClr val="F8F9FA"/>
+                  <a:srgbClr val="FAF3E7"/>
                 </a:solidFill>
                 <a:latin typeface="Arial" pitchFamily="34" charset="0"/>
                 <a:ea typeface="Arial" pitchFamily="34" charset="-122"/>
@@ -3693,7 +3902,7 @@
             <a:r>
               <a:rPr lang="en-US" sz="1140" b="1" i="1" dirty="0">
                 <a:solidFill>
-                  <a:srgbClr val="0F172A"/>
+                  <a:srgbClr val="64748B"/>
                 </a:solidFill>
                 <a:latin typeface="Arial" pitchFamily="34" charset="0"/>
                 <a:ea typeface="Arial" pitchFamily="34" charset="-122"/>
@@ -3760,7 +3969,7 @@
             <a:r>
               <a:rPr lang="en-US" sz="720" b="1" dirty="0">
                 <a:solidFill>
-                  <a:srgbClr val="0F172A"/>
+                  <a:srgbClr val="B45309"/>
                 </a:solidFill>
                 <a:latin typeface="Arial" pitchFamily="34" charset="0"/>
                 <a:ea typeface="Arial" pitchFamily="34" charset="-122"/>
@@ -4132,7 +4341,7 @@
             <a:r>
               <a:rPr lang="en-US" sz="1140" b="1" i="1" dirty="0">
                 <a:solidFill>
-                  <a:srgbClr val="0F172A"/>
+                  <a:srgbClr val="64748B"/>
                 </a:solidFill>
                 <a:latin typeface="Arial" pitchFamily="34" charset="0"/>
                 <a:ea typeface="Arial" pitchFamily="34" charset="-122"/>
@@ -4199,7 +4408,7 @@
             <a:r>
               <a:rPr lang="en-US" sz="720" b="1" dirty="0">
                 <a:solidFill>
-                  <a:srgbClr val="0F172A"/>
+                  <a:srgbClr val="B45309"/>
                 </a:solidFill>
                 <a:latin typeface="Arial" pitchFamily="34" charset="0"/>
                 <a:ea typeface="Arial" pitchFamily="34" charset="-122"/>
@@ -4283,7 +4492,7 @@
             <a:r>
               <a:rPr lang="en-US" sz="869" b="1" i="1" dirty="0">
                 <a:solidFill>
-                  <a:srgbClr val="0F172A"/>
+                  <a:srgbClr val="64748B"/>
                 </a:solidFill>
                 <a:latin typeface="Arial" pitchFamily="34" charset="0"/>
                 <a:ea typeface="Arial" pitchFamily="34" charset="-122"/>
@@ -4367,7 +4576,7 @@
             <a:r>
               <a:rPr lang="en-US" sz="613" i="1" dirty="0">
                 <a:solidFill>
-                  <a:srgbClr val="0F172A"/>
+                  <a:srgbClr val="64748B"/>
                 </a:solidFill>
                 <a:latin typeface="Arial" pitchFamily="34" charset="0"/>
                 <a:ea typeface="Arial" pitchFamily="34" charset="-122"/>

</xml_diff>